<commit_message>
deck_pdi + brief: shutter frame, 1 lam/D pinhole, step-error first numbers
Co-Authored-By: Claude Fable 5.1 <noreply@anthropic.com>
Claude-Session: https://claude.ai/code/session_01RuX6Hc5txP1E9QGjcSo42d
</commit_message>
<xml_diff>
--- a/demo_session/deck_pdi.pptx
+++ b/demo_session/deck_pdi.pptx
@@ -6799,7 +6799,7 @@
                 </a:solidFill>
                 <a:latin typeface="Arial"/>
               </a:rPr>
-              <a:t>•  Shutter frame (the reference alone, once per state, 5 frames): [R2].</a:t>
+              <a:t>•  A reference frame per state (the pinhole alone, a fifth frame) makes the pinhole reading the waveguide reading's twin on every row and the ladder: 1.02 / 1.06 / 1.13 at 120 / 240 / 480 nm.  The pinhole's fold was the flat-DM reference-intensity assumption, not the pinhole.</a:t>
             </a:r>
           </a:p>
           <a:p>
@@ -6815,7 +6815,7 @@
                 </a:solidFill>
                 <a:latin typeface="Arial"/>
               </a:rPr>
-              <a:t>•  A 1 λ/D pinhole: [R2].</a:t>
+              <a:t>•  A 1 λ/D pinhole (the classical regime; 0.28 plate transmission, 29% of the light, visibility 0.94) has no fold even with that assumption: the same 1.02 / 1.06 / 1.13, the same rows; 2.9×10¹⁴ camera photons per picometer.</a:t>
             </a:r>
           </a:p>
           <a:p>
@@ -6831,7 +6831,7 @@
                 </a:solidFill>
                 <a:latin typeface="Arial"/>
               </a:rPr>
-              <a:t>•  A 2% step-size error, four-step least squares against the five-frame Schwider–Hariharan scan: [R2].</a:t>
+              <a:t>•  A 2% step-size error: the flat reads 0.069 rad rms under four-step least squares and 1.3×10⁻⁵ rad under the five-frame Schwider–Hariharan scan; the differential rows: [R2].</a:t>
             </a:r>
           </a:p>
         </p:txBody>

</xml_diff>

<commit_message>
deck_pdi + brief: the loop rows for P and PF
Co-Authored-By: Claude Fable 5.1 <noreply@anthropic.com>
Claude-Session: https://claude.ai/code/session_01RuX6Hc5txP1E9QGjcSo42d
</commit_message>
<xml_diff>
--- a/demo_session/deck_pdi.pptx
+++ b/demo_session/deck_pdi.pptx
@@ -7045,7 +7045,7 @@
                 </a:solidFill>
                 <a:latin typeface="Arial"/>
               </a:rPr>
-              <a:t>In closed loop: the hold metric with a camera that drifts</a:t>
+              <a:t>In closed loop the stepped pinhole costs the stepped dimple's light and the waveguide reference three times that</a:t>
             </a:r>
           </a:p>
           <a:p>
@@ -7061,7 +7061,7 @@
                 </a:solidFill>
                 <a:latin typeface="Arial"/>
               </a:rPr>
-              <a:t>[CAM] filled from runs/ploop193, pcam193, pcam193i</a:t>
+              <a:t>Held to 3 pm against a 2 pm random walk from 7.0×10¹² photons per cycle (pinhole) and 2.5×10¹³ (waveguide); camera-drift rows [CAM] from runs/pcam193, pcam193i</a:t>
             </a:r>
           </a:p>
         </p:txBody>
@@ -7689,7 +7689,7 @@
                           </a:solidFill>
                           <a:latin typeface="Arial"/>
                         </a:rPr>
-                        <a:t>[CAM]</a:t>
+                        <a:t>2.3×10¹²</a:t>
                       </a:r>
                     </a:p>
                   </a:txBody>
@@ -7711,7 +7711,7 @@
                           </a:solidFill>
                           <a:latin typeface="Arial"/>
                         </a:rPr>
-                        <a:t>[CAM]</a:t>
+                        <a:t>7.0×10¹²</a:t>
                       </a:r>
                     </a:p>
                   </a:txBody>
@@ -7733,7 +7733,7 @@
                           </a:solidFill>
                           <a:latin typeface="Arial"/>
                         </a:rPr>
-                        <a:t>[CAM]</a:t>
+                        <a:t>9.9 pm</a:t>
                       </a:r>
                     </a:p>
                   </a:txBody>
@@ -7801,7 +7801,7 @@
                           </a:solidFill>
                           <a:latin typeface="Arial"/>
                         </a:rPr>
-                        <a:t>[CAM]</a:t>
+                        <a:t>7.0×10¹²</a:t>
                       </a:r>
                     </a:p>
                   </a:txBody>
@@ -7823,7 +7823,7 @@
                           </a:solidFill>
                           <a:latin typeface="Arial"/>
                         </a:rPr>
-                        <a:t>[CAM]</a:t>
+                        <a:t>2.5×10¹³</a:t>
                       </a:r>
                     </a:p>
                   </a:txBody>
@@ -7845,7 +7845,7 @@
                           </a:solidFill>
                           <a:latin typeface="Arial"/>
                         </a:rPr>
-                        <a:t>[CAM]</a:t>
+                        <a:t>9.9 pm</a:t>
                       </a:r>
                     </a:p>
                   </a:txBody>
@@ -7882,15 +7882,78 @@
           </a:graphicData>
         </a:graphic>
       </p:graphicFrame>
-      <p:sp>
-        <p:nvSpPr>
-          <p:cNvPr id="6" name="TextBox 5"/>
+      <p:pic>
+        <p:nvPicPr>
+          <p:cNvPr id="6" name="Picture 5" descr="ploop193_loop.png"/>
+          <p:cNvPicPr>
+            <a:picLocks noChangeAspect="1"/>
+          </p:cNvPicPr>
+          <p:nvPr/>
+        </p:nvPicPr>
+        <p:blipFill>
+          <a:blip r:embed="rId2"/>
+          <a:stretch>
+            <a:fillRect/>
+          </a:stretch>
+        </p:blipFill>
+        <p:spPr>
+          <a:xfrm>
+            <a:off x="7616720" y="4050791"/>
+            <a:ext cx="2963119" cy="1287272"/>
+          </a:xfrm>
+          <a:prstGeom prst="rect">
+            <a:avLst/>
+          </a:prstGeom>
+        </p:spPr>
+      </p:pic>
+      <p:sp>
+        <p:nvSpPr>
+          <p:cNvPr id="7" name="TextBox 6"/>
           <p:cNvSpPr txBox="1"/>
           <p:nvPr/>
         </p:nvSpPr>
         <p:spPr>
           <a:xfrm>
-            <a:off x="6400800" y="4050791"/>
+            <a:off x="6400800" y="5356351"/>
+            <a:ext cx="5394960" cy="724408"/>
+          </a:xfrm>
+          <a:prstGeom prst="rect">
+            <a:avLst/>
+          </a:prstGeom>
+          <a:noFill/>
+        </p:spPr>
+        <p:txBody>
+          <a:bodyPr wrap="square">
+            <a:spAutoFit/>
+          </a:bodyPr>
+          <a:lstStyle/>
+          <a:p>
+            <a:pPr algn="ctr">
+              <a:spcAft>
+                <a:spcPts val="0"/>
+              </a:spcAft>
+            </a:pPr>
+            <a:r>
+              <a:rPr sz="1000" b="0">
+                <a:solidFill>
+                  <a:srgbClr val="6E6E6E"/>
+                </a:solidFill>
+                <a:latin typeface="Arial"/>
+              </a:rPr>
+              <a:t>Steady-state hold error against photons per cycle for the stepped pinhole (red) and the waveguide reference (brown) under no drift (dotted), the 2 pm random walk (solid) and the 5 pm thermal ramp (dashed); the 3 pm hold level marked.  Right panel of the runner's figure.</a:t>
+            </a:r>
+          </a:p>
+        </p:txBody>
+      </p:sp>
+      <p:sp>
+        <p:nvSpPr>
+          <p:cNvPr id="8" name="TextBox 7"/>
+          <p:cNvSpPr txBox="1"/>
+          <p:nvPr/>
+        </p:nvSpPr>
+        <p:spPr>
+          <a:xfrm>
+            <a:off x="6400800" y="6117335"/>
             <a:ext cx="5394960" cy="274320"/>
           </a:xfrm>
           <a:prstGeom prst="rect">
@@ -7916,7 +7979,7 @@
                 </a:solidFill>
                 <a:latin typeface="Arial"/>
               </a:rPr>
-              <a:t>dm_gauge_lib/dmg_loop, shared with the interferometer; drift seed 77 on the full actuator grid.</a:t>
+              <a:t>dm_gauge_lib/dmg_loop, shared with the interferometer; drift seed 77 on the full actuator grid; matrix measured on the working surface.  Both PDI readings contract at 0.509 per cycle with no fixed error (steps return to 0.000 pm).</a:t>
             </a:r>
           </a:p>
         </p:txBody>

</xml_diff>

<commit_message>
deck_pdi + brief: the camera drift's electron form is invisible at the campaign's photon levels; relative form pending
Co-Authored-By: Claude Fable 5.1 <noreply@anthropic.com>
Claude-Session: https://claude.ai/code/session_01RuX6Hc5txP1E9QGjcSo42d
</commit_message>
<xml_diff>
--- a/demo_session/deck_pdi.pptx
+++ b/demo_session/deck_pdi.pptx
@@ -7160,7 +7160,23 @@
                 </a:solidFill>
                 <a:latin typeface="Arial"/>
               </a:rPr>
-              <a:t>•  The camera knob: every pixel's offset random-walks 0.13 electrons per cycle (about 1 electron over the run, the paper's 12-hour figure compressed), constant within a scan.  Readings whose step weights sum to zero (S, P, PF) subtract it exactly; the single-frame readings and the simultaneous pair see the walk and put it on the DM.</a:t>
+              <a:t>•  The camera knob: every pixel's offset random-walks, constant within a scan.  Readings whose step weights sum to zero (S, P, PF) subtract it exactly; the single-frame readings and the simultaneous pair see the walk and put it on the DM (the loop's unit test shows both).</a:t>
+            </a:r>
+          </a:p>
+          <a:p>
+            <a:pPr>
+              <a:spcAft>
+                <a:spcPts val="600"/>
+              </a:spcAft>
+            </a:pPr>
+            <a:r>
+              <a:rPr sz="1200" b="0">
+                <a:solidFill>
+                  <a:srgbClr val="282828"/>
+                </a:solidFill>
+                <a:latin typeface="Arial"/>
+              </a:rPr>
+              <a:t>•  At the paper's 1 electron per pixel it is invisible to every reading: a lit pixel collects 3×10⁸ photons per frame at 10¹³ per measurement, so an electron is 10⁻⁴ of its shot noise.  The immunity argument belongs to Roman's photon-starved sensor (10² to 10³ per pixel per frame over 12 hours).  The drift is therefore also run as a fraction of the signal, 10⁻³ per cycle.</a:t>
             </a:r>
           </a:p>
           <a:p>
@@ -7191,7 +7207,7 @@
         </p:nvGraphicFramePr>
         <p:xfrm>
           <a:off x="6400800" y="1298448"/>
-          <a:ext cx="5394957" cy="2606040"/>
+          <a:ext cx="5394956" cy="3291840"/>
         </p:xfrm>
         <a:graphic>
           <a:graphicData uri="http://schemas.openxmlformats.org/drawingml/2006/table">
@@ -7200,13 +7216,14 @@
                 <a:tableStyleId>{5C22544A-7EE6-4342-B048-85BDC9FD1C3A}</a:tableStyleId>
               </a:tblPr>
               <a:tblGrid>
-                <a:gridCol w="823150"/>
-                <a:gridCol w="960342"/>
-                <a:gridCol w="914611"/>
+                <a:gridCol w="537567"/>
+                <a:gridCol w="627162"/>
+                <a:gridCol w="597297"/>
                 <a:gridCol w="1004823"/>
-                <a:gridCol w="1692031"/>
+                <a:gridCol w="1433513"/>
+                <a:gridCol w="1194594"/>
               </a:tblGrid>
-              <a:tr h="434340">
+              <a:tr h="605790">
                 <a:tc>
                   <a:txBody>
                     <a:bodyPr wrap="square"/>
@@ -7307,7 +7324,29 @@
                           </a:solidFill>
                           <a:latin typeface="Arial"/>
                         </a:rPr>
-                        <a:t>camera walk, 10¹⁵ photons: hold error</a:t>
+                        <a:t>camera walk of 1 e per pixel: hold error at 10¹⁵</a:t>
+                      </a:r>
+                    </a:p>
+                  </a:txBody>
+                  <a:tcPr marL="54864" marR="54864" marT="18288" marB="18288">
+                    <a:solidFill>
+                      <a:srgbClr val="1F4E79"/>
+                    </a:solidFill>
+                  </a:tcPr>
+                </a:tc>
+                <a:tc>
+                  <a:txBody>
+                    <a:bodyPr wrap="square"/>
+                    <a:lstStyle/>
+                    <a:p>
+                      <a:r>
+                        <a:rPr sz="1000" b="1">
+                          <a:solidFill>
+                            <a:srgbClr val="FFFFFF"/>
+                          </a:solidFill>
+                          <a:latin typeface="Arial"/>
+                        </a:rPr>
+                        <a:t>camera walk of 10⁻³ of the signal: [CAM]</a:t>
                       </a:r>
                     </a:p>
                   </a:txBody>
@@ -7419,6 +7458,28 @@
                           </a:solidFill>
                           <a:latin typeface="Arial"/>
                         </a:rPr>
+                        <a:t>0.15 pm (= no drift)</a:t>
+                      </a:r>
+                    </a:p>
+                  </a:txBody>
+                  <a:tcPr marL="54864" marR="54864" marT="18288" marB="18288">
+                    <a:solidFill>
+                      <a:srgbClr val="FFFFFF"/>
+                    </a:solidFill>
+                  </a:tcPr>
+                </a:tc>
+                <a:tc>
+                  <a:txBody>
+                    <a:bodyPr wrap="square"/>
+                    <a:lstStyle/>
+                    <a:p>
+                      <a:r>
+                        <a:rPr sz="1000" b="0">
+                          <a:solidFill>
+                            <a:srgbClr val="282828"/>
+                          </a:solidFill>
+                          <a:latin typeface="Arial"/>
+                        </a:rPr>
                         <a:t>[CAM]</a:t>
                       </a:r>
                     </a:p>
@@ -7531,6 +7592,28 @@
                           </a:solidFill>
                           <a:latin typeface="Arial"/>
                         </a:rPr>
+                        <a:t>0.12 pm (= no drift)</a:t>
+                      </a:r>
+                    </a:p>
+                  </a:txBody>
+                  <a:tcPr marL="54864" marR="54864" marT="18288" marB="18288">
+                    <a:solidFill>
+                      <a:srgbClr val="ECF1F6"/>
+                    </a:solidFill>
+                  </a:tcPr>
+                </a:tc>
+                <a:tc>
+                  <a:txBody>
+                    <a:bodyPr wrap="square"/>
+                    <a:lstStyle/>
+                    <a:p>
+                      <a:r>
+                        <a:rPr sz="1000" b="0">
+                          <a:solidFill>
+                            <a:srgbClr val="282828"/>
+                          </a:solidFill>
+                          <a:latin typeface="Arial"/>
+                        </a:rPr>
                         <a:t>[CAM]</a:t>
                       </a:r>
                     </a:p>
@@ -7542,7 +7625,7 @@
                   </a:tcPr>
                 </a:tc>
               </a:tr>
-              <a:tr h="434340">
+              <a:tr h="605790">
                 <a:tc>
                   <a:txBody>
                     <a:bodyPr wrap="square"/>
@@ -7643,6 +7726,28 @@
                           </a:solidFill>
                           <a:latin typeface="Arial"/>
                         </a:rPr>
+                        <a:t>0.14 pm (= no drift)</a:t>
+                      </a:r>
+                    </a:p>
+                  </a:txBody>
+                  <a:tcPr marL="54864" marR="54864" marT="18288" marB="18288">
+                    <a:solidFill>
+                      <a:srgbClr val="FFFFFF"/>
+                    </a:solidFill>
+                  </a:tcPr>
+                </a:tc>
+                <a:tc>
+                  <a:txBody>
+                    <a:bodyPr wrap="square"/>
+                    <a:lstStyle/>
+                    <a:p>
+                      <a:r>
+                        <a:rPr sz="1000" b="0">
+                          <a:solidFill>
+                            <a:srgbClr val="282828"/>
+                          </a:solidFill>
+                          <a:latin typeface="Arial"/>
+                        </a:rPr>
                         <a:t>[CAM]</a:t>
                       </a:r>
                     </a:p>
@@ -7654,7 +7759,7 @@
                   </a:tcPr>
                 </a:tc>
               </a:tr>
-              <a:tr h="434340">
+              <a:tr h="605790">
                 <a:tc>
                   <a:txBody>
                     <a:bodyPr wrap="square"/>
@@ -7755,6 +7860,28 @@
                           </a:solidFill>
                           <a:latin typeface="Arial"/>
                         </a:rPr>
+                        <a:t>0.14 pm (= no drift)</a:t>
+                      </a:r>
+                    </a:p>
+                  </a:txBody>
+                  <a:tcPr marL="54864" marR="54864" marT="18288" marB="18288">
+                    <a:solidFill>
+                      <a:srgbClr val="ECF1F6"/>
+                    </a:solidFill>
+                  </a:tcPr>
+                </a:tc>
+                <a:tc>
+                  <a:txBody>
+                    <a:bodyPr wrap="square"/>
+                    <a:lstStyle/>
+                    <a:p>
+                      <a:r>
+                        <a:rPr sz="1000" b="0">
+                          <a:solidFill>
+                            <a:srgbClr val="282828"/>
+                          </a:solidFill>
+                          <a:latin typeface="Arial"/>
+                        </a:rPr>
                         <a:t>[CAM]</a:t>
                       </a:r>
                     </a:p>
@@ -7766,7 +7893,7 @@
                   </a:tcPr>
                 </a:tc>
               </a:tr>
-              <a:tr h="434340">
+              <a:tr h="605790">
                 <a:tc>
                   <a:txBody>
                     <a:bodyPr wrap="square"/>
@@ -7846,6 +7973,28 @@
                           <a:latin typeface="Arial"/>
                         </a:rPr>
                         <a:t>9.9 pm</a:t>
+                      </a:r>
+                    </a:p>
+                  </a:txBody>
+                  <a:tcPr marL="54864" marR="54864" marT="18288" marB="18288">
+                    <a:solidFill>
+                      <a:srgbClr val="FFFFFF"/>
+                    </a:solidFill>
+                  </a:tcPr>
+                </a:tc>
+                <a:tc>
+                  <a:txBody>
+                    <a:bodyPr wrap="square"/>
+                    <a:lstStyle/>
+                    <a:p>
+                      <a:r>
+                        <a:rPr sz="1000" b="0">
+                          <a:solidFill>
+                            <a:srgbClr val="282828"/>
+                          </a:solidFill>
+                          <a:latin typeface="Arial"/>
+                        </a:rPr>
+                        <a:t>0.25 pm (= no drift)</a:t>
                       </a:r>
                     </a:p>
                   </a:txBody>
@@ -7898,8 +8047,8 @@
         </p:blipFill>
         <p:spPr>
           <a:xfrm>
-            <a:off x="7616720" y="4050791"/>
-            <a:ext cx="2963119" cy="1287272"/>
+            <a:off x="7679864" y="4736592"/>
+            <a:ext cx="2836830" cy="1232408"/>
           </a:xfrm>
           <a:prstGeom prst="rect">
             <a:avLst/>
@@ -7914,7 +8063,7 @@
         </p:nvSpPr>
         <p:spPr>
           <a:xfrm>
-            <a:off x="6400800" y="5356351"/>
+            <a:off x="6400800" y="5987288"/>
             <a:ext cx="5394960" cy="724408"/>
           </a:xfrm>
           <a:prstGeom prst="rect">
@@ -7953,7 +8102,7 @@
         </p:nvSpPr>
         <p:spPr>
           <a:xfrm>
-            <a:off x="6400800" y="6117335"/>
+            <a:off x="6400800" y="6748272"/>
             <a:ext cx="5394960" cy="274320"/>
           </a:xfrm>
           <a:prstGeom prst="rect">

</xml_diff>

<commit_message>
deck_pdi + brief: within-scan camera drift
Co-Authored-By: Claude Fable 5.1 <noreply@anthropic.com>
Claude-Session: https://claude.ai/code/session_01RuX6Hc5txP1E9QGjcSo42d
</commit_message>
<xml_diff>
--- a/demo_session/deck_pdi.pptx
+++ b/demo_session/deck_pdi.pptx
@@ -3969,7 +3969,7 @@
                 </a:solidFill>
                 <a:latin typeface="Arial"/>
               </a:rPr>
-              <a:t>•  A drifting camera reaches only the readings that do not phase-step: at 10⁻³ of the signal per cycle the linear reading puts 10.8 nm on the DM and the polarized pair 89 pm; the stepped dimple, the stepped pinhole and the waveguide reading are unaffected to the printed digit.  At the paper's 1 electron per pixel nothing is affected at these light levels.  [CAM] what within-scan drift costs the stepped readings.</a:t>
+              <a:t>•  A drifting camera reaches only the readings that do not phase-step: at 10⁻³ of the signal per cycle the linear reading puts 10.8 nm on the DM and the polarized pair 89 pm; the stepped dimple, the stepped pinhole and the waveguide reading are unaffected to the printed digit.  At the paper's 1 electron per pixel nothing is affected at these light levels; drift developing within a scan costs the stepped readings 5 to 11 pm, so the scan rate, not the reading, sets that floor.</a:t>
             </a:r>
           </a:p>
           <a:p>
@@ -8411,7 +8411,7 @@
                 </a:solidFill>
                 <a:latin typeface="Arial"/>
               </a:rPr>
-              <a:t>•  Within-scan drift (the whole step developing across the frames): what the zero-sum readings pay: [CAM].</a:t>
+              <a:t>•  Within-scan drift (the whole step developing across the frames of each scan): the stepped readings pay for the frame-to-frame part, 5.4 pm (dimple), 5.3 pm (pinhole), 10.7 pm (waveguide) at 10¹⁵ photons, 2000× below the single-frame reading; the scan rate is the hardware lever.</a:t>
             </a:r>
           </a:p>
         </p:txBody>

</xml_diff>

<commit_message>
deck_pdi: the P/SRI as a buildable two-arm bench -- sketch and two-arm traced render replace the single-arm layout slides; brief: the bench design and its three traps
Co-Authored-By: Claude Fable 5.1 <noreply@anthropic.com>
Claude-Session: https://claude.ai/code/session_01RuX6Hc5txP1E9QGjcSo42d
</commit_message>
<xml_diff>
--- a/demo_session/deck_pdi.pptx
+++ b/demo_session/deck_pdi.pptx
@@ -5612,7 +5612,7 @@
                 </a:solidFill>
                 <a:latin typeface="Arial"/>
               </a:rPr>
-              <a:t>The bench as traced, source to camera</a:t>
+              <a:t>The P/SRI as a buildable bench: two arms, split and recombined, the pinhole and the phase shifter in the reference arm</a:t>
             </a:r>
           </a:p>
           <a:p>
@@ -5628,7 +5628,7 @@
                 </a:solidFill>
                 <a:latin typeface="Arial"/>
               </a:rPr>
-              <a:t>Collimator 857 mm, 7° splitter, 700 mm leg to the 96 mm DM, focusing lens 429 mm, the mask seat (16) inside the sphere bracket, 42.5 mm relay, camera at the DM image</a:t>
+              <a:t>Behind the DM return a 45° plate splits the beam; the test arm runs the top and right legs, the reference arm the left and bottom legs through a focusing lens, the pinhole seat and a recollimating lens; a second plate recombines them into the pupil-imaging tail and one camera</a:t>
             </a:r>
           </a:p>
         </p:txBody>
@@ -5679,7 +5679,7 @@
       </p:sp>
       <p:pic>
         <p:nvPicPr>
-          <p:cNvPr id="4" name="Picture 3" descr="pdi_layout.png"/>
+          <p:cNvPr id="4" name="Picture 3" descr="psri_layout.png"/>
           <p:cNvPicPr>
             <a:picLocks noChangeAspect="1"/>
           </p:cNvPicPr>
@@ -5693,8 +5693,8 @@
         </p:blipFill>
         <p:spPr>
           <a:xfrm>
-            <a:off x="639926" y="1298448"/>
-            <a:ext cx="10911843" cy="3903472"/>
+            <a:off x="3238558" y="1298448"/>
+            <a:ext cx="5714578" cy="3298952"/>
           </a:xfrm>
           <a:prstGeom prst="rect">
             <a:avLst/>
@@ -5709,8 +5709,8 @@
         </p:nvSpPr>
         <p:spPr>
           <a:xfrm>
-            <a:off x="411480" y="5220208"/>
-            <a:ext cx="11368735" cy="394208"/>
+            <a:off x="411480" y="4615688"/>
+            <a:ext cx="11368735" cy="724408"/>
           </a:xfrm>
           <a:prstGeom prst="rect">
             <a:avLst/>
@@ -5735,7 +5735,7 @@
                 </a:solidFill>
                 <a:latin typeface="Arial"/>
               </a:rPr>
-              <a:t>Looking down on the bench; distances in millimeters along the chief ray in blue.  Source and 21 mm baffle (1), collimator (2, 3), splitter plate at 7° (4 to 6, 10 to 12), the DM (7, radius 51 mm) on its 700 mm leg, focusing lens (13, 14), and the tail to the camera (20), enlarged on the next slide.</a:t>
+              <a:t>Looking down on the bench (test deck in orange, reference arm in blue; distances in millimeters along the chief ray).  The TG96 front end is unchanged to the recombination plane (12); the splitter BS2 (13) starts the Mach–Zehnder: the test arm to the fold M1 (15, 320 mm), the lens-glass compensator (16–17) and 758 mm down to BS3 (18); the reference arm 120 mm to Lr1 (14), 300 mm to the pinhole seat (17) inside its sphere bracket, 300 mm to Lr2 (20), the fold M3 (22) and the bottom leg to BS3, where it transmits; then L2 (19), the empty seat (21), the relay (22–23) and the camera (24) at the image of the DM.</a:t>
             </a:r>
           </a:p>
         </p:txBody>
@@ -5748,7 +5748,7 @@
         </p:nvSpPr>
         <p:spPr>
           <a:xfrm>
-            <a:off x="411480" y="5650992"/>
+            <a:off x="411480" y="5376672"/>
             <a:ext cx="11368735" cy="274320"/>
           </a:xfrm>
           <a:prstGeom prst="rect">
@@ -5774,7 +5774,7 @@
                 </a:solidFill>
                 <a:latin typeface="Arial"/>
               </a:rPr>
-              <a:t>The Zernike sensor's deck, unchanged (tg96 test arm, tuned tail; mask trim −5.58 mm to the true focus); the pinhole plate replaces the dimple plate in seat 16.  The P/SRI's reference arm (a 60/40 plate splitter before the focusing lens, a waveguide chip at a second focus, a recombiner; paper Fig. 3) is not traced: its reference is the waveguide mode's field at the pupil, scaled by the coupling of the traced focal field.</a:t>
+              <a:t>macos.design.psri_bench: each arm transmits one plate and reflects off the other's front face (equal plate glass); a 21.9 mm normal-incidence plate in the test arm nulls the reference lenses' glass so the two chief optical paths from the source to the camera are equal to the digit (4453.1 mm); the bottom fold is placed so the exit chiefs coincide (2×10⁻¹³ mm).  Lr1's conic (−0.578) is solved on the traced bench for a 0.1 µm ray blur at the pinhole, which sits at the true focus (+1.10 mm from the thin-lens seat); Lr2 is Lr1's mirror image about the pinhole, so it recollimates the pinhole's wave exactly.  The photonic chip with its thermo-optic phase shifter occupies the pinhole seat; both plates are 60/40 in power.</a:t>
             </a:r>
           </a:p>
         </p:txBody>
@@ -5831,7 +5831,7 @@
                 </a:solidFill>
                 <a:latin typeface="Arial"/>
               </a:rPr>
-              <a:t>The last 130 mm: mask seat, exit sphere, relay lens, camera</a:t>
+              <a:t>The two arms traced</a:t>
             </a:r>
           </a:p>
           <a:p>
@@ -5847,7 +5847,7 @@
                 </a:solidFill>
                 <a:latin typeface="Arial"/>
               </a:rPr>
-              <a:t>The exit sphere (17) carries the entrance sphere's radius, so the unmasked round trip is the identity; the relay (18, 19) reimages the DM onto the camera (20)</a:t>
+              <a:t>Test arm (green) and reference arm (blue) through the pinhole focus, recombined at the second plate into the shared tail; every ray of both decks reaches the camera and the two chief rays land on the same pixel</a:t>
             </a:r>
           </a:p>
         </p:txBody>
@@ -5898,7 +5898,7 @@
       </p:sp>
       <p:pic>
         <p:nvPicPr>
-          <p:cNvPr id="4" name="Picture 3" descr="pdi_layout_tail.png"/>
+          <p:cNvPr id="4" name="Picture 3" descr="psri_render.png"/>
           <p:cNvPicPr>
             <a:picLocks noChangeAspect="1"/>
           </p:cNvPicPr>
@@ -5912,8 +5912,8 @@
         </p:blipFill>
         <p:spPr>
           <a:xfrm>
-            <a:off x="2408701" y="1298448"/>
-            <a:ext cx="7374293" cy="3903472"/>
+            <a:off x="1017734" y="1298448"/>
+            <a:ext cx="10156227" cy="3555492"/>
           </a:xfrm>
           <a:prstGeom prst="rect">
             <a:avLst/>
@@ -5928,8 +5928,8 @@
         </p:nvSpPr>
         <p:spPr>
           <a:xfrm>
-            <a:off x="411480" y="5220208"/>
-            <a:ext cx="11368735" cy="394208"/>
+            <a:off x="411480" y="4872228"/>
+            <a:ext cx="11368735" cy="559307"/>
           </a:xfrm>
           <a:prstGeom prst="rect">
             <a:avLst/>
@@ -5954,7 +5954,7 @@
                 </a:solidFill>
                 <a:latin typeface="Arial"/>
               </a:rPr>
-              <a:t>The tail at 14× the bench scale: focus at the mask seat (16), the exit sphere (17) 23.9 mm behind it, the relay lens (18, 19) 15.9 mm further, and the camera (20) 32.4 mm behind the relay.</a:t>
+              <a:t>The rig as traced by the engine, from above the bench and in ISO view (labels are the test deck's): the source and collimator at left, the DM (E7) on its 700 mm leg, the splitter and its compensator, the Mach–Zehnder with the test arm's fold (E15), compensator slab (E16–E17) and recombiner (E18); the reference arm, unlabeled, down the left leg through its focusing lens to the pinhole focus, the recollimating lens and the bottom fold; then the focusing lens (E19), the relay and the camera (E24).</a:t>
             </a:r>
           </a:p>
         </p:txBody>
@@ -5967,7 +5967,7 @@
         </p:nvSpPr>
         <p:spPr>
           <a:xfrm>
-            <a:off x="411480" y="5650992"/>
+            <a:off x="411480" y="5468112"/>
             <a:ext cx="11368735" cy="274320"/>
           </a:xfrm>
           <a:prstGeom prst="rect">
@@ -5993,7 +5993,7 @@
                 </a:solidFill>
                 <a:latin typeface="Arial"/>
               </a:rPr>
-              <a:t>Seat 16 holds the dimple (Zernike readings), the pinhole plate (P), or nothing (PF).  The focal-plane grid inside the bracket samples the mask at 3.96 pixels per λ/D (1024 grid, 193 rays), 7.9 pixels across the 2 λ/D pinhole.</a:t>
+              <a:t>Two decks (psri_test.in, psri_ref.in) traced separately, as the Twyman–Green is; both send 3210 of 3210 rays to the camera, chief rays 2×10⁻¹² mm apart, camera planes coincident to 3×10⁻¹³ mm, ray footprints 3.60 and 3.29 mm.  The collimated beam behind the DM carries the front end's 5.8 µm rms collimation residual, which the tuned tail lens cancels for the test arm and the pinhole removes from the reference; with Lr2 mirroring Lr1 the recollimated reference reproduces that wave to 0.5% (5.78 against 5.80 µm, the reversibility check).  The readings on the following slides used a reference synthesized from the test deck's field; running them on this two-deck bench is the next step.</a:t>
             </a:r>
           </a:p>
         </p:txBody>
@@ -8034,7 +8034,7 @@
                 </a:solidFill>
                 <a:latin typeface="Arial"/>
               </a:rPr>
-              <a:t>•  A 2% step-size error: the absolute reading carries it (0.069 rad rms on the flat under four-step least squares, 1.3×10⁻⁵ under the five-frame Schwider–Hariharan scan; 3.5% error on a 12 nm figure), the differential rows barely notice (single 0.992 / 4 pm against 0.994 / 4): the error is common to both states and cancels in the difference.  Schwider–Hariharan differential rows: [R2].</a:t>
+              <a:t>•  A 2% step-size error: the absolute reading carries it (0.069 rad rms on the flat under four-step least squares, 1.3×10⁻⁵ under the five-frame Schwider–Hariharan scan; 3.5% error on a 12 nm figure), the differential rows barely notice (single 0.992 / 4 pm against 0.994 / 4): the error is common to both states and cancels in the difference.  The five-frame scan takes the absolute error to 4.9 pm (pinhole) and 2.2 pm (waveguide) and returns the differential rows to the error-free values exactly, for one extra frame.</a:t>
             </a:r>
           </a:p>
         </p:txBody>

</xml_diff>

<commit_message>
deck_pdi slides 5-6: the buildable P/SRI bench (sketch with larger labels) and the two-arm traced render; final balance numbers
Co-Authored-By: Claude Fable 5.1 <noreply@anthropic.com>
Claude-Session: https://claude.ai/code/session_01RuX6Hc5txP1E9QGjcSo42d
</commit_message>
<xml_diff>
--- a/demo_session/deck_pdi.pptx
+++ b/demo_session/deck_pdi.pptx
@@ -5612,7 +5612,7 @@
                 </a:solidFill>
                 <a:latin typeface="Arial"/>
               </a:rPr>
-              <a:t>The P/SRI as a buildable bench: two arms, split and recombined, the pinhole and the phase shifter in the reference arm</a:t>
+              <a:t>The P/SRI as a buildable bench: two balanced arms</a:t>
             </a:r>
           </a:p>
           <a:p>
@@ -5628,7 +5628,7 @@
                 </a:solidFill>
                 <a:latin typeface="Arial"/>
               </a:rPr>
-              <a:t>Behind the DM return a 45° plate splits the beam; the test arm runs the top and right legs, the reference arm the left and bottom legs through a focusing lens, the pinhole seat and a recollimating lens; a second plate recombines them into the pupil-imaging tail and one camera</a:t>
+              <a:t>A 45° plate behind the DM return splits the beam; the reference arm focuses onto the pinhole seat and recollimates, the test arm folds around it; a second plate recombines both into one camera</a:t>
             </a:r>
           </a:p>
         </p:txBody>
@@ -5693,8 +5693,8 @@
         </p:blipFill>
         <p:spPr>
           <a:xfrm>
-            <a:off x="3238558" y="1298448"/>
-            <a:ext cx="5714578" cy="3298952"/>
+            <a:off x="2266040" y="1298448"/>
+            <a:ext cx="7659615" cy="4360672"/>
           </a:xfrm>
           <a:prstGeom prst="rect">
             <a:avLst/>
@@ -5709,8 +5709,8 @@
         </p:nvSpPr>
         <p:spPr>
           <a:xfrm>
-            <a:off x="411480" y="4615688"/>
-            <a:ext cx="11368735" cy="724408"/>
+            <a:off x="411480" y="5677408"/>
+            <a:ext cx="11368735" cy="394208"/>
           </a:xfrm>
           <a:prstGeom prst="rect">
             <a:avLst/>
@@ -5735,7 +5735,7 @@
                 </a:solidFill>
                 <a:latin typeface="Arial"/>
               </a:rPr>
-              <a:t>Looking down on the bench (test deck in orange, reference arm in blue; distances in millimeters along the chief ray).  The TG96 front end is unchanged to the recombination plane (12); the splitter BS2 (13) starts the Mach–Zehnder: the test arm to the fold M1 (15, 320 mm), the lens-glass compensator (16–17) and 758 mm down to BS3 (18); the reference arm 120 mm to Lr1 (14), 300 mm to the pinhole seat (17) inside its sphere bracket, 300 mm to Lr2 (20), the fold M3 (22) and the bottom leg to BS3, where it transmits; then L2 (19), the empty seat (21), the relay (22–23) and the camera (24) at the image of the DM.</a:t>
+              <a:t>Looking down on the bench: test deck orange, reference arm blue, leg lengths in millimeters; BS2 (13) splits, M1 (15), the compensator (16–17) and BS3 (18) carry the test arm, Lr1 (14), the pinhole (17), Lr2 (20) and M3 (22) the reference arm; then L2 (19), the relay and the camera (24).</a:t>
             </a:r>
           </a:p>
         </p:txBody>
@@ -5748,7 +5748,7 @@
         </p:nvSpPr>
         <p:spPr>
           <a:xfrm>
-            <a:off x="411480" y="5376672"/>
+            <a:off x="411480" y="6108192"/>
             <a:ext cx="11368735" cy="274320"/>
           </a:xfrm>
           <a:prstGeom prst="rect">
@@ -5774,7 +5774,7 @@
                 </a:solidFill>
                 <a:latin typeface="Arial"/>
               </a:rPr>
-              <a:t>macos.design.psri_bench: each arm transmits one plate and reflects off the other's front face (equal plate glass); a 21.9 mm normal-incidence plate in the test arm nulls the reference lenses' glass so the two chief optical paths from the source to the camera are equal to the digit (4453.1 mm); the bottom fold is placed so the exit chiefs coincide (2×10⁻¹³ mm).  Lr1's conic (−0.578) is solved on the traced bench for a 0.1 µm ray blur at the pinhole, which sits at the true focus (+1.10 mm from the thin-lens seat); Lr2 is Lr1's mirror image about the pinhole, so it recollimates the pinhole's wave exactly.  The photonic chip with its thermo-optic phase shifter occupies the pinhole seat; both plates are 60/40 in power.</a:t>
+              <a:t>macos.design.psri_bench: equal plate glass per arm; a 21.9 mm plate in the test arm nulls the lens glass (chief optical paths 4453.1 mm each); M3 placed so the exit chiefs coincide (2×10⁻¹³ mm); Lr1 conic −0.578 (0.1 µm blur), pinhole at the true focus (+1.10 mm), Lr2 = Lr1 mirrored; the photonic chip and its phase shifter occupy the pinhole seat; both plates 60/40.</a:t>
             </a:r>
           </a:p>
         </p:txBody>

</xml_diff>